<commit_message>
Add team members to Review 1, report and presentation; refresh zip
Co-Authored-By: Claude Opus 5.5 <noreply@anthropic.com>
Claude-Session: https://claude.ai/code/session_01RBCZvHRngDWn2z2Egxvtcp
</commit_message>
<xml_diff>
--- a/docs/VisionGuard_Presentation.pptx
+++ b/docs/VisionGuard_Presentation.pptx
@@ -131,7 +131,7 @@
   <p:extLst>
     <p:ext uri="{521415D9-36F7-43E2-AB2F-B90AF26B5E84}">
       <p14:sectionLst xmlns:p14="http://schemas.microsoft.com/office/powerpoint/2010/main">
-        <p14:section name="Introduction" id="{ad2f3c01-0559-1672-fb04-b7c99fc5b1aa}">
+        <p14:section name="Introduction" id="{fab8049b-7fe6-3cff-ae29-0fa3a5a69e4c}">
           <p14:sldIdLst>
             <p14:sldId id="256"/>
             <p14:sldId id="257"/>
@@ -141,7 +141,7 @@
             <p14:sldId id="261"/>
           </p14:sldIdLst>
         </p14:section>
-        <p14:section name="System Design" id="{87ea2201-aea8-60a5-c3c0-84c026a3779a}">
+        <p14:section name="System Design" id="{d92d8618-1380-1eca-9d0d-32ca589bdd77}">
           <p14:sldIdLst>
             <p14:sldId id="262"/>
             <p14:sldId id="263"/>
@@ -153,7 +153,7 @@
             <p14:sldId id="269"/>
           </p14:sldIdLst>
         </p14:section>
-        <p14:section name="Software" id="{efd32022-2bcb-82e6-b62f-8e83e6fade06}">
+        <p14:section name="Software" id="{565b609d-7be6-0507-2196-d4e80f11d67a}">
           <p14:sldIdLst>
             <p14:sldId id="270"/>
             <p14:sldId id="271"/>
@@ -161,7 +161,7 @@
             <p14:sldId id="273"/>
           </p14:sldIdLst>
         </p14:section>
-        <p14:section name="Results and Conclusion" id="{b0c34f4d-8af3-28d1-9bcc-866040cfb42f}">
+        <p14:section name="Results and Conclusion" id="{6b815ae2-7d39-2a54-d59b-b5ce54f731c8}">
           <p14:sldIdLst>
             <p14:sldId id="274"/>
             <p14:sldId id="275"/>
@@ -846,7 +846,7 @@
           <a:p>
             <a:r>
               <a:rPr lang="en-US" dirty="0"/>
-              <a:t>Good morning. Our project is VisionGuard, a smart cane for visually impaired people. It warns the user about obstacles in front and about water or wet ground at the tip, using an Arduino Nano, an ultrasonic sensor and a moisture probe.</a:t>
+              <a:t>Good morning. We are S Darshan and Tanay Agarwal. Our project is VisionGuard, a smart cane for visually impaired people. It warns the user about obstacles in front and about water or wet ground at the tip, using an Arduino Nano, an ultrasonic sensor and a moisture probe.</a:t>
             </a:r>
             <a:endParaRPr lang="en-US" dirty="0"/>
           </a:p>
@@ -3717,8 +3717,8 @@
         </p:nvSpPr>
         <p:spPr>
           <a:xfrm>
-            <a:off x="548640" y="3886200"/>
-            <a:ext cx="4572000" cy="548640"/>
+            <a:off x="548640" y="3840480"/>
+            <a:ext cx="4754880" cy="594360"/>
           </a:xfrm>
           <a:prstGeom prst="rect">
             <a:avLst/>
@@ -3739,7 +3739,7 @@
                   <a:schemeClr val="bg1"/>
                 </a:solidFill>
               </a:rPr>
-              <a:t>Darshan S</a:t>
+              <a:t>S Darshan (25BCE2883)  ·  Tanay Agarwal (25BCE2475)</a:t>
             </a:r>
             <a:endParaRPr lang="en-US" sz="1300" dirty="0"/>
           </a:p>

</xml_diff>

<commit_message>
Fill VIT Vellore B.Tech CSE details in submissions and presentation; refresh zip
Co-Authored-By: Claude Opus 5.5 <noreply@anthropic.com>
Claude-Session: https://claude.ai/code/session_01RBCZvHRngDWn2z2Egxvtcp
</commit_message>
<xml_diff>
--- a/docs/VisionGuard_Presentation.pptx
+++ b/docs/VisionGuard_Presentation.pptx
@@ -131,7 +131,7 @@
   <p:extLst>
     <p:ext uri="{521415D9-36F7-43E2-AB2F-B90AF26B5E84}">
       <p14:sectionLst xmlns:p14="http://schemas.microsoft.com/office/powerpoint/2010/main">
-        <p14:section name="Introduction" id="{fab8049b-7fe6-3cff-ae29-0fa3a5a69e4c}">
+        <p14:section name="Introduction" id="{49c36b42-e81a-b415-26de-f744d6cf8b86}">
           <p14:sldIdLst>
             <p14:sldId id="256"/>
             <p14:sldId id="257"/>
@@ -141,7 +141,7 @@
             <p14:sldId id="261"/>
           </p14:sldIdLst>
         </p14:section>
-        <p14:section name="System Design" id="{d92d8618-1380-1eca-9d0d-32ca589bdd77}">
+        <p14:section name="System Design" id="{6add6ddb-72fd-7030-5904-b2d9b0901845}">
           <p14:sldIdLst>
             <p14:sldId id="262"/>
             <p14:sldId id="263"/>
@@ -153,7 +153,7 @@
             <p14:sldId id="269"/>
           </p14:sldIdLst>
         </p14:section>
-        <p14:section name="Software" id="{565b609d-7be6-0507-2196-d4e80f11d67a}">
+        <p14:section name="Software" id="{8d0f1fa0-b823-0a71-b809-c68edfb3c920}">
           <p14:sldIdLst>
             <p14:sldId id="270"/>
             <p14:sldId id="271"/>
@@ -161,7 +161,7 @@
             <p14:sldId id="273"/>
           </p14:sldIdLst>
         </p14:section>
-        <p14:section name="Results and Conclusion" id="{6b815ae2-7d39-2a54-d59b-b5ce54f731c8}">
+        <p14:section name="Results and Conclusion" id="{28423bf7-b9b9-f09d-55c0-820fe8060926}">
           <p14:sldIdLst>
             <p14:sldId id="274"/>
             <p14:sldId id="275"/>
@@ -3753,7 +3753,7 @@
                   <a:schemeClr val="bg1"/>
                 </a:solidFill>
               </a:rPr>
-              <a:t>BACSE324 Embedded Systems Architecture  |  Course Project</a:t>
+              <a:t>BACSE324 Embedded Systems Architecture  |  B.Tech CSE, VIT Vellore</a:t>
             </a:r>
             <a:endParaRPr lang="en-US" sz="1300" dirty="0"/>
           </a:p>

</xml_diff>

<commit_message>
Add two-speaker presentation script and put it in the slide notes
Co-Authored-By: Claude Opus 5.5 <noreply@anthropic.com>
Claude-Session: https://claude.ai/code/session_01RBCZvHRngDWn2z2Egxvtcp
</commit_message>
<xml_diff>
--- a/docs/VisionGuard_Presentation.pptx
+++ b/docs/VisionGuard_Presentation.pptx
@@ -131,7 +131,7 @@
   <p:extLst>
     <p:ext uri="{521415D9-36F7-43E2-AB2F-B90AF26B5E84}">
       <p14:sectionLst xmlns:p14="http://schemas.microsoft.com/office/powerpoint/2010/main">
-        <p14:section name="Introduction" id="{09b87343-c8d3-aa62-0ae5-02d6b066e33c}">
+        <p14:section name="Introduction" id="{24e559c4-5a6b-2bfe-1a05-1034528d3406}">
           <p14:sldIdLst>
             <p14:sldId id="256"/>
             <p14:sldId id="257"/>
@@ -141,7 +141,7 @@
             <p14:sldId id="261"/>
           </p14:sldIdLst>
         </p14:section>
-        <p14:section name="System Design" id="{4d06a7a3-2fac-ee51-d85e-cc654896d100}">
+        <p14:section name="System Design" id="{3916ad36-2b31-b0fd-8f00-67eedbcdf5b1}">
           <p14:sldIdLst>
             <p14:sldId id="262"/>
             <p14:sldId id="263"/>
@@ -153,7 +153,7 @@
             <p14:sldId id="269"/>
           </p14:sldIdLst>
         </p14:section>
-        <p14:section name="Software" id="{3cd56ecf-efb0-a6d4-3b85-39fe3bdb0ba1}">
+        <p14:section name="Software" id="{7707901a-8c0f-9e48-bd7f-dd8e300ae3e5}">
           <p14:sldIdLst>
             <p14:sldId id="270"/>
             <p14:sldId id="271"/>
@@ -161,7 +161,7 @@
             <p14:sldId id="273"/>
           </p14:sldIdLst>
         </p14:section>
-        <p14:section name="Results and Conclusion" id="{4545a690-9b43-736d-ac8d-371e736616dd}">
+        <p14:section name="Results and Conclusion" id="{b963f2db-12da-3235-9207-d4ce0c4443ab}">
           <p14:sldIdLst>
             <p14:sldId id="274"/>
             <p14:sldId id="275"/>
@@ -846,7 +846,11 @@
           <a:p>
             <a:r>
               <a:rPr lang="en-US" dirty="0"/>
-              <a:t>Good morning. We are S Darshan and Tanay Agarwal. Our project is VisionGuard, a smart cane for visually impaired people. It warns the user about obstacles in front and about water or wet ground at the tip, using an Arduino Nano, an ultrasonic sensor and a moisture probe.</a:t>
+              <a:t>SPEAKER: BOTH  (~25 s)
+ACTION: Stand on either side of the screen. Darshan holds the cane.
+DARSHAN: Good morning, sir. I'm S Darshan, registration number 25BCE2883.
+TANAY: And I'm Tanay Agarwal, 25BCE2475.
+DARSHAN: Our project is VisionGuard, a smart cane for visually impaired people. It warns the user about obstacles in front of them and about water at the tip of the cane.</a:t>
             </a:r>
             <a:endParaRPr lang="en-US" dirty="0"/>
           </a:p>
@@ -934,7 +938,9 @@
           <a:p>
             <a:r>
               <a:rPr lang="en-US" dirty="0"/>
-              <a:t>The Nano sends a 10 microsecond pulse on Trig. The sensor emits eight 40 kHz pulses and holds Echo high until the echo returns. Distance equals speed of sound times time, divided by two because the sound goes there and back. For example, 1000 microseconds gives 17 centimetres.</a:t>
+              <a:t>SPEAKER: DARSHAN  (~45 s)
+ACTION: Point at steps 1, 2, 3, then the formula box.
+DARSHAN: This is how the ultrasonic sensor works. Step one: the Nano sends a 10-microsecond pulse to the Trig pin. Step two: the sensor sends out eight sound pulses at 40 kilohertz, which is too high for us to hear. Step three: the Echo pin stays HIGH until the echo comes back. So distance equals speed of sound times time, divided by two. We divide by two because the sound goes to the object and comes back. The speed of sound is about 0.034 centimetres per microsecond, so if the echo takes 1000 microseconds, the distance is 17 centimetres.</a:t>
             </a:r>
             <a:endParaRPr lang="en-US" dirty="0"/>
           </a:p>
@@ -1022,7 +1028,10 @@
           <a:p>
             <a:r>
               <a:rPr lang="en-US" dirty="0"/>
-              <a:t>The probe has two copper tracks. Dry air does not conduct, so the reading is near 1023. Water conducts, the resistance drops, and the voltage on A0 falls. Below 500 we treat it as water. Because the ADC reference and the divider use the same supply, the reading does not depend on the battery voltage.</a:t>
+              <a:t>SPEAKER: DARSHAN  (~45 s)
+ACTION: Point at the probe on the real cane. End by turning towards Tanay.
+DARSHAN: This is the moisture probe at the tip. It has two copper strips. Dry air doesn't conduct electricity, but water does, so when the tip touches water, the resistance between the strips drops. The LM393 module turns this into a voltage, and the Nano reads it on A0. When it's dry the reading is about 1023, and when it's wet it goes below 500. We use the analog output instead of the digital D0 pin, so we can set the threshold in the code.
+DARSHAN: Now Tanay will explain the power system and the circuit.</a:t>
             </a:r>
             <a:endParaRPr lang="en-US" dirty="0"/>
           </a:p>
@@ -1110,7 +1119,9 @@
           <a:p>
             <a:r>
               <a:rPr lang="en-US" dirty="0"/>
-              <a:t>One 18650 lithium-ion cell powers everything through a rocker switch connected to the Nano's 5V pin. Total draw is about 40 mA, so the 1200 mAh cell lasts roughly 30 hours in theory. A capacitor smooths the supply. Important: switch off before connecting USB, because the battery is wired directly to the 5V rail.</a:t>
+              <a:t>SPEAKER: TANAY  (~35 s)
+ACTION: Point at battery → switch → 5V pin, then the warning.
+TANAY: Thank you. The cane runs on one 18650 lithium-ion battery: 3.7 volts, 1200 milliamp-hours. It goes through the rocker switch to the Nano's 5V pin, which also powers both sensors. We didn't use the VIN pin, because VIN needs about 7 volts. The whole cane draws around 40 milliamps, so in theory the battery can last about 30 hours. One safety point: we always switch the cane off before connecting USB, because the battery is connected directly to the 5V line.</a:t>
             </a:r>
             <a:endParaRPr lang="en-US" dirty="0"/>
           </a:p>
@@ -1198,7 +1209,9 @@
           <a:p>
             <a:r>
               <a:rPr lang="en-US" dirty="0"/>
-              <a:t>All modules share the 5 volt and ground rails. Trig goes to D5, Echo to D6, the moisture output to A0 and the buzzer to D2. D3 is reserved for a vibration motor in the next version.</a:t>
+              <a:t>SPEAKER: TANAY  (~40 s)
+ACTION: Point at the red 5V line and black GND line first.
+TANAY: This is the full circuit. The red line is 5 volts and the black line is ground. Every module shares them. Trig goes to D5, Echo to D6, the moisture signal to A0 and the buzzer to D2. In the final cane we didn't use a breadboard. The sensors have header pins, so we connected them with female jumper wires, and the other ends are soldered directly to the Nano. All the 5V wires join at the Nano's 5V pin and all the grounds at GND. Soldering is stronger, because a cane shakes all the time and breadboard wires would come loose.</a:t>
             </a:r>
             <a:endParaRPr lang="en-US" dirty="0"/>
           </a:p>
@@ -1286,7 +1299,8 @@
           <a:p>
             <a:r>
               <a:rPr lang="en-US" dirty="0"/>
-              <a:t>This table shows every connection. Note that the moisture module's digital output D0 is not used; we read the analog value so we can set the threshold in software.</a:t>
+              <a:t>SPEAKER: TANAY  (~20 s)
+TANAY: This table lists every connection. The main pins to remember are D5 for Trig, D6 for Echo, A0 for moisture and D2 for the buzzer. The LM393's D0 pin isn't used.</a:t>
             </a:r>
             <a:endParaRPr lang="en-US" dirty="0"/>
           </a:p>
@@ -1374,7 +1388,9 @@
           <a:p>
             <a:r>
               <a:rPr lang="en-US" dirty="0"/>
-              <a:t>The loop: initialise once, then measure distance, read moisture, and decide. Water has first priority with a continuous tone. Otherwise, if an obstacle is within 50 cm, it beeps with a gap from 50 to 400 ms depending on distance. Otherwise it is silent. Then it waits 30 ms and repeats.</a:t>
+              <a:t>SPEAKER: TANAY  (~45 s)
+ACTION: Point at boxes 1 to 6 in order.
+TANAY: This is our algorithm. First the Nano sets up the pins. Then, in a loop, it measures the distance and reads the moisture. Then it decides. If the moisture is below 500, that's water, so the buzzer stays on continuously. If not, and an obstacle is closer than 50 centimetres, it beeps for 50 milliseconds and then waits a gap between 50 and 400 milliseconds depending on the distance. Otherwise the path is clear and the buzzer stays off. Then it waits 30 milliseconds and repeats.</a:t>
             </a:r>
             <a:endParaRPr lang="en-US" dirty="0"/>
           </a:p>
@@ -1462,7 +1478,9 @@
           <a:p>
             <a:r>
               <a:rPr lang="en-US" dirty="0"/>
-              <a:t>The data flow graph shows the computation: the echo time is multiplied by 0.034 and divided by 2 to get distance. Distance goes to a comparison for 'near' and to constrain and map to get the beep gap. The moisture value is compared with 500 to get 'wet'. The priority select combines them to drive the buzzer.</a:t>
+              <a:t>SPEAKER: TANAY  (~35 s)
+ACTION: Trace the top path, then the bottom path, then the priority box.
+TANAY: The data flow graph shows how the data is processed. The echo time t is multiplied by 0.034 and divided by 2 to get the distance d. The distance is used in two places: to check whether the obstacle is near, and to work out the beep gap g. The moisture value m is compared with 500 to decide whether it's wet. Finally, the priority block uses wet, near and g to control the buzzer.</a:t>
             </a:r>
             <a:endParaRPr lang="en-US" dirty="0"/>
           </a:p>
@@ -1550,7 +1568,9 @@
           <a:p>
             <a:r>
               <a:rPr lang="en-US" dirty="0"/>
-              <a:t>After switch-on, the system initialises and then senses. From SENSE it goes into exactly one state: water alert, obstacle alert or clear. Each returns to SENSE after 30 milliseconds. Switching off returns it to OFF from any state.</a:t>
+              <a:t>SPEAKER: TANAY  (~30 s)
+ACTION: Follow the arrows from OFF to SENSE, then the three states.
+TANAY: This is the state diagram. When the switch is turned on, the cane sets up once and goes to SENSE. From SENSE it goes into exactly one state: water alert, obstacle alert or clear. After 30 milliseconds it comes back to SENSE. Turning the switch off takes it back to OFF from any state.</a:t>
             </a:r>
             <a:endParaRPr lang="en-US" dirty="0"/>
           </a:p>
@@ -1638,7 +1658,10 @@
           <a:p>
             <a:r>
               <a:rPr lang="en-US" dirty="0"/>
-              <a:t>This is the core code, simplified. readDistanceCm sends the trigger pulse and measures the echo with a 30 ms timeout. Then the if-else chain implements the priority: water first, then obstacle with map() giving the beep gap, otherwise off.</a:t>
+              <a:t>SPEAKER: TANAY  (~40 s)
+ACTION: Point at the top half of the code, then the bottom half. End by turning towards Darshan.
+TANAY: This is the main part of our code. The readDistanceCm function sends the trigger pulse and uses pulseIn with a 30-millisecond timeout. Without the timeout, it would wait up to one second when there's no echo and freeze the cane. Below that is the if-else chain. Water is checked first, so it always has priority. The map function converts the distance into the beep gap.
+TANAY: Now Darshan will show you the prototype.</a:t>
             </a:r>
             <a:endParaRPr lang="en-US" dirty="0"/>
           </a:p>
@@ -1726,7 +1749,11 @@
           <a:p>
             <a:r>
               <a:rPr lang="en-US" dirty="0"/>
-              <a:t>This is the built prototype. From the tip: the moisture probe, the LM393 module, the ultrasonic sensor facing forward, then the Nano with the buzzer, the switch and the battery near the handle, which keeps it easy to swing.</a:t>
+              <a:t>SPEAKER: DARSHAN  (~60 s)
+ACTION: DEMO: switch on → hand from far to near → dip tip in water.
+DARSHAN: This is our prototype. From the bottom: the moisture probe, the LM393 module, the ultrasonic sensor facing forward, then the Nano with the buzzer, the switch and the battery near the handle, so it's easy to swing.
+DARSHAN: Let me show you. I'm switching it on. It's silent now because the path is clear. Now I'll move my hand closer. It starts beeping at 50 centimetres and gets faster as I get closer. Now I'll dip the tip in water. It gives a continuous beep, which means water is detected.
+DARSHAN: Tanay will now show our test results.</a:t>
             </a:r>
             <a:endParaRPr lang="en-US" dirty="0"/>
           </a:p>
@@ -1814,7 +1841,8 @@
           <a:p>
             <a:r>
               <a:rPr lang="en-US" dirty="0"/>
-              <a:t>This is the flow of the talk: the problem, our objectives, the system design, the software, the results, and finally the limitations and future scope.</a:t>
+              <a:t>SPEAKER: DARSHAN  (~20 s)
+DARSHAN: First I'll explain the problem, our objectives, the system design and the sensors. Then Tanay will cover the power, circuit, software, results, cost and future scope.</a:t>
             </a:r>
             <a:endParaRPr lang="en-US" dirty="0"/>
           </a:p>
@@ -1902,7 +1930,9 @@
           <a:p>
             <a:r>
               <a:rPr lang="en-US" dirty="0"/>
-              <a:t>Testing so far: the cane runs on battery and the obstacle alert works, with beeps getting faster as the obstacle approaches. The water alert is implemented and we are calibrating the threshold from the dry and wet readings on the Serial Monitor.</a:t>
+              <a:t>SPEAKER: TANAY  (~30 s)
+ACTION: Point at the Result column.
+TANAY: These are our tests. Running on battery and the obstacle alert are both verified. The water alert is in the code, and we're calibrating the exact threshold using the dry and wet readings on the Serial Monitor. We'll update this table once that's done.</a:t>
             </a:r>
             <a:endParaRPr lang="en-US" dirty="0"/>
           </a:p>
@@ -1990,7 +2020,9 @@
           <a:p>
             <a:r>
               <a:rPr lang="en-US" dirty="0"/>
-              <a:t>The cane hardware costs about 876 rupees. The full project spend was 1,805 rupees, but that includes the soldering iron and other tools, and parts kept for the next version such as the MOSFET and fuse. That is far cheaper than commercial smart canes.</a:t>
+              <a:t>SPEAKER: TANAY  (~25 s)
+ACTION: Point at ₹876.
+TANAY: The parts on the cane cost about 876 rupees. Our total spending was 1,805 rupees, but that includes tools like the soldering iron and extra parts for the next version, like the MOSFET and the fuse. That's much cheaper than commercial smart canes.</a:t>
             </a:r>
             <a:endParaRPr lang="en-US" dirty="0"/>
           </a:p>
@@ -2078,7 +2110,9 @@
           <a:p>
             <a:r>
               <a:rPr lang="en-US" dirty="0"/>
-              <a:t>Advantages: early warning with distance information, water detection, low cost and easy repair. Limitations: the narrow beam misses head-level obstacles, water is detected only on contact, the probe corrodes, the supply is unregulated, and a buzzer can be hard to hear in traffic.</a:t>
+              <a:t>SPEAKER: TANAY  (~35 s)
+ACTION: Left box first, then right box.
+TANAY: The advantages: it warns before the user hits an obstacle, it shows the distance through the beep speed, it detects water, and it's cheap and easy to repair. The limitations, to be honest: the sensor's beam is narrow, so it can miss head-level objects. Water is detected only when the tip touches it. The probe will corrode over time. The battery isn't regulated. And the buzzer can be hard to hear in traffic.</a:t>
             </a:r>
             <a:endParaRPr lang="en-US" dirty="0"/>
           </a:p>
@@ -2166,7 +2200,8 @@
           <a:p>
             <a:r>
               <a:rPr lang="en-US" dirty="0"/>
-              <a:t>For the final version we plan a vibration motor for silent alerts, regulated power with charging and a fuse, extra sensors for head-level obstacles and steps, a capacitive moisture sensor, GPS with an SOS message, and a PCB in a waterproof enclosure.</a:t>
+              <a:t>SPEAKER: TANAY  (~30 s)
+TANAY: To fix these, we plan to add a vibration motor using the MOSFET, so the user can feel the alerts. We also plan proper power with a boost converter, a charger and a fuse; extra sensors pointing up and down for head-level objects and steps; a capacitive moisture sensor that won't corrode; GPS with an SOS message; and finally a PCB inside a waterproof box.</a:t>
             </a:r>
             <a:endParaRPr lang="en-US" dirty="0"/>
           </a:p>
@@ -2254,7 +2289,8 @@
           <a:p>
             <a:r>
               <a:rPr lang="en-US" dirty="0"/>
-              <a:t>These are the datasheets and documentation we used.</a:t>
+              <a:t>SPEAKER: TANAY  (~10 s)
+TANAY: These are the datasheets and documents we referred to.</a:t>
             </a:r>
             <a:endParaRPr lang="en-US" dirty="0"/>
           </a:p>
@@ -2342,7 +2378,10 @@
           <a:p>
             <a:r>
               <a:rPr lang="en-US" dirty="0"/>
-              <a:t>To conclude: VisionGuard turns a plain cane into a low-cost electronic travel aid that warns about obstacles before contact, shows distance through the beep rate, and gives priority warnings for water, all for under 900 rupees. Thank you. We are happy to take questions.</a:t>
+              <a:t>SPEAKER: BOTH  (~25 s)
+ACTION: Both face the faculty.
+DARSHAN: To conclude, VisionGuard turns a normal cane into a low-cost electronic aid. It warns about obstacles early, shows the distance through the beep speed, and gives a priority warning for water, all for under 900 rupees.
+TANAY: Thank you, sir. We're happy to answer any questions.</a:t>
             </a:r>
             <a:endParaRPr lang="en-US" dirty="0"/>
           </a:p>
@@ -2430,7 +2469,9 @@
           <a:p>
             <a:r>
               <a:rPr lang="en-US" dirty="0"/>
-              <a:t>Millions of people depend on the white cane. Its limits: it detects an obstacle only on contact, it cannot warn about water or open drains, and it gives no idea of distance.</a:t>
+              <a:t>SPEAKER: DARSHAN  (~40 s)
+ACTION: Point at the 2.2 billion figure, then the three points.
+DARSHAN: According to the WHO, about 2.2 billion people around the world have some kind of vision impairment. Most blind people use a white cane, but it has three problems. First, it finds an obstacle only when it actually hits it. Second, it can't warn about water, puddles or open drains. Third, it doesn't tell the user how far away the obstacle is.</a:t>
             </a:r>
             <a:endParaRPr lang="en-US" dirty="0"/>
           </a:p>
@@ -2518,7 +2559,9 @@
           <a:p>
             <a:r>
               <a:rPr lang="en-US" dirty="0"/>
-              <a:t>A white cane is cheap but contact-only. Guide dogs are excellent but expensive and scarce. Commercial smart canes are costly and imported. Our project targets the gap: a low-cost cane that warns about both obstacles and water.</a:t>
+              <a:t>SPEAKER: DARSHAN  (~35 s)
+ACTION: Move left to right across the three boxes.
+DARSHAN: We looked at what already exists. A white cane is cheap and simple, but it works only on contact. A guide dog is very helpful, but it's expensive, needs long training and isn't easily available. There are commercial smart canes, but they're costly, mostly imported and hard to repair here. So the gap we saw is a low-cost cane that warns early about both obstacles and water.</a:t>
             </a:r>
             <a:endParaRPr lang="en-US" dirty="0"/>
           </a:p>
@@ -2606,7 +2649,9 @@
           <a:p>
             <a:r>
               <a:rPr lang="en-US" dirty="0"/>
-              <a:t>Four measurable objectives: detect obstacles within 50 cm; show distance through the beep gap, from 50 ms when very close to 400 ms at 50 cm; detect water when the moisture reading drops below 500 out of 1023, with priority; and keep the cane cheap and portable, about 876 rupees of hardware on one battery.</a:t>
+              <a:t>SPEAKER: DARSHAN  (~40 s)
+ACTION: Point at each number as you say it.
+DARSHAN: We set four objectives. One: detect obstacles within 50 centimetres. Two: show the distance through the beep speed. The gap between beeps goes from 50 milliseconds when the obstacle is very close to 400 milliseconds at 50 centimetres. Three: detect water when the moisture reading drops below 500 out of 1023, and give that the highest priority. Four: keep it cheap and portable. The cane parts cost about 876 rupees, and it runs on one battery.</a:t>
             </a:r>
             <a:endParaRPr lang="en-US" dirty="0"/>
           </a:p>
@@ -2694,7 +2739,9 @@
           <a:p>
             <a:r>
               <a:rPr lang="en-US" dirty="0"/>
-              <a:t>Our solution adds three things to a PVC cane: an ultrasonic sensor as its eyes, a moisture probe at the tip, and a buzzer that gives prioritised alerts. An Arduino Nano runs it all from a single 18650 battery.</a:t>
+              <a:t>SPEAKER: DARSHAN  (~35 s)
+ACTION: Hold up the cane next to the photo.
+DARSHAN: Our solution has three main parts on a PVC pipe: an ultrasonic sensor that works like the cane's eyes, a moisture probe at the tip, and a buzzer that gives alerts by priority. The idea actually started as a smart shoe. We moved it to a cane because the cane tip reaches water before the foot does, and a sensor on the shaft stays steadier than one on a moving shoe.</a:t>
             </a:r>
             <a:endParaRPr lang="en-US" dirty="0"/>
           </a:p>
@@ -2782,7 +2829,9 @@
           <a:p>
             <a:r>
               <a:rPr lang="en-US" dirty="0"/>
-              <a:t>Inputs on the left: the ultrasonic sensor on D5 and D6, and the moisture probe through the LM393 module on A0. The Nano in the middle decides. The output is the buzzer on D2. Power comes from the battery through the switch to the 5V pin. The dashed vibration motor is planned, not built yet.</a:t>
+              <a:t>SPEAKER: DARSHAN  (~40 s)
+ACTION: Trace the diagram left, middle, right, then top.
+DARSHAN: This is our block diagram. On the left are the inputs: the ultrasonic sensor connected to pins D5 and D6, and the moisture probe connected through the LM393 module to pin A0. In the middle is the Arduino Nano, which makes all the decisions. On the right is the output, the buzzer on pin D2. At the top, the battery powers everything through the on/off switch. The dashed box is a vibration motor, which we plan to add later.</a:t>
             </a:r>
             <a:endParaRPr lang="en-US" dirty="0"/>
           </a:p>
@@ -2870,7 +2919,9 @@
           <a:p>
             <a:r>
               <a:rPr lang="en-US" dirty="0"/>
-              <a:t>These are the eight electronic parts. The Nano is the brain, the HC-SR04 measures distance, the probe and LM393 module sense water, the buzzer alerts, and the battery, switch and capacitor make up the power system.</a:t>
+              <a:t>SPEAKER: DARSHAN  (~35 s)
+ACTION: Go across the top row, then the bottom row.
+DARSHAN: These are the eight parts we used. The Arduino Nano is the controller. The HC-SR04 measures distance. The moisture probe and the LM393 module detect water. The active buzzer gives the alerts. The 18650 battery, the rocker switch and a capacitor make up the power side. The capacitor smooths the supply so the Nano doesn't reset when the buzzer switches on.</a:t>
             </a:r>
             <a:endParaRPr lang="en-US" dirty="0"/>
           </a:p>
@@ -2958,7 +3009,8 @@
           <a:p>
             <a:r>
               <a:rPr lang="en-US" dirty="0"/>
-              <a:t>We chose the Arduino Nano because it is small enough for a cane, cheap, uses 5 volt logic like our sensors, has a built-in 10-bit ADC for the moisture probe, and is easy to program over USB. A Raspberry Pi would be overkill in cost, power and size.</a:t>
+              <a:t>SPEAKER: DARSHAN  (~30 s)
+DARSHAN: We chose the Arduino Nano because it's small, only 18 by 45 millimetres, so it fits on a cane. It costs about 250 rupees. It uses 5-volt logic like our sensors, and it has a built-in 10-bit ADC to read the moisture sensor. It's also easy to program over USB. A Raspberry Pi would be too expensive and power-hungry for a simple job like this.</a:t>
             </a:r>
             <a:endParaRPr lang="en-US" dirty="0"/>
           </a:p>

</xml_diff>

<commit_message>
Presentation: new photos, 220 uF capacitor, correct header-pin wiring, assembly slide
Co-Authored-By: Claude Opus 5.5 <noreply@anthropic.com>
Claude-Session: https://claude.ai/code/session_01RBCZvHRngDWn2z2Egxvtcp
</commit_message>
<xml_diff>
--- a/docs/VisionGuard_Presentation.pptx
+++ b/docs/VisionGuard_Presentation.pptx
@@ -131,7 +131,7 @@
   <p:extLst>
     <p:ext uri="{521415D9-36F7-43E2-AB2F-B90AF26B5E84}">
       <p14:sectionLst xmlns:p14="http://schemas.microsoft.com/office/powerpoint/2010/main">
-        <p14:section name="Introduction" id="{24e559c4-5a6b-2bfe-1a05-1034528d3406}">
+        <p14:section name="Introduction" id="{1a6e3766-f72f-8748-af7d-b6b299d4ee24}">
           <p14:sldIdLst>
             <p14:sldId id="256"/>
             <p14:sldId id="257"/>
@@ -141,7 +141,7 @@
             <p14:sldId id="261"/>
           </p14:sldIdLst>
         </p14:section>
-        <p14:section name="System Design" id="{3916ad36-2b31-b0fd-8f00-67eedbcdf5b1}">
+        <p14:section name="System Design" id="{53747080-8f19-97bf-6de8-a36b3553f8f9}">
           <p14:sldIdLst>
             <p14:sldId id="262"/>
             <p14:sldId id="263"/>
@@ -153,7 +153,7 @@
             <p14:sldId id="269"/>
           </p14:sldIdLst>
         </p14:section>
-        <p14:section name="Software" id="{7707901a-8c0f-9e48-bd7f-dd8e300ae3e5}">
+        <p14:section name="Software" id="{fca74e68-2fe6-01ce-ed75-7adeeac78d16}">
           <p14:sldIdLst>
             <p14:sldId id="270"/>
             <p14:sldId id="271"/>
@@ -161,7 +161,7 @@
             <p14:sldId id="273"/>
           </p14:sldIdLst>
         </p14:section>
-        <p14:section name="Results and Conclusion" id="{b963f2db-12da-3235-9207-d4ce0c4443ab}">
+        <p14:section name="Results and Conclusion" id="{1089706e-deb7-842b-2a9a-55e8336065bf}">
           <p14:sldIdLst>
             <p14:sldId id="274"/>
             <p14:sldId id="275"/>
@@ -1211,7 +1211,7 @@
               <a:rPr lang="en-US" dirty="0"/>
               <a:t>SPEAKER: TANAY  (~40 s)
 ACTION: Point at the red 5V line and black GND line first.
-TANAY: This is the full circuit. The red line is 5 volts and the black line is ground. Every module shares them. Trig goes to D5, Echo to D6, the moisture signal to A0 and the buzzer to D2. In the final cane we didn't use a breadboard. The sensors have header pins, so we connected them with female jumper wires, and the other ends are soldered directly to the Nano. All the 5V wires join at the Nano's 5V pin and all the grounds at GND. Soldering is stronger, because a cane shakes all the time and breadboard wires would come loose.</a:t>
+TANAY: This is the full circuit. The red line is 5 volts and the black line is ground. Every module shares them. Trig goes to D5, Echo to D6, the moisture signal to A0 and the buzzer to D2. In the final cane we didn't use a breadboard. We soldered male header pins onto the Nano, and since the sensors also have header pins, the signal wires are female jumper wires plugged onto both ends. The power wires, the buzzer and the 220 microfarad capacitor are soldered for a strong connection.</a:t>
             </a:r>
             <a:endParaRPr lang="en-US" dirty="0"/>
           </a:p>
@@ -1749,9 +1749,9 @@
           <a:p>
             <a:r>
               <a:rPr lang="en-US" dirty="0"/>
-              <a:t>SPEAKER: DARSHAN  (~60 s)
-ACTION: DEMO: switch on → hand from far to near → dip tip in water.
-DARSHAN: This is our prototype. From the bottom: the moisture probe, the LM393 module, the ultrasonic sensor facing forward, then the Nano with the buzzer, the switch and the battery near the handle, so it's easy to swing.
+              <a:t>SPEAKER: DARSHAN  (~75 s)
+ACTION: Point at the photos, then at the real cane. DEMO: switch on → hand from far to near → dip tip in water.
+DARSHAN: This is our prototype and how we put it together. We soldered male header pins onto the Nano and connected the sensors with female jumper wires: Trig to D5, Echo to D6 and the moisture output to A0. The power wires, the buzzer and the capacitor are soldered. All the parts are hot-glued to the PVC pipe, the ultrasonic sensor sits on a foam spacer, and the battery holder is cable-tied. From the bottom: the probe, the LM393 module, the ultrasonic sensor, the Nano with the buzzer, then the switch and battery near the handle.
 DARSHAN: Let me show you. I'm switching it on. It's silent now because the path is clear. Now I'll move my hand closer. It starts beeping at 50 centimetres and gets faster as I get closer. Now I'll dip the tip in water. It gives a continuous beep, which means water is detected.
 DARSHAN: Tanay will now show our test results.</a:t>
             </a:r>
@@ -2921,7 +2921,7 @@
               <a:rPr lang="en-US" dirty="0"/>
               <a:t>SPEAKER: DARSHAN  (~35 s)
 ACTION: Go across the top row, then the bottom row.
-DARSHAN: These are the eight parts we used. The Arduino Nano is the controller. The HC-SR04 measures distance. The moisture probe and the LM393 module detect water. The active buzzer gives the alerts. The 18650 battery, the rocker switch and a capacitor make up the power side. The capacitor smooths the supply so the Nano doesn't reset when the buzzer switches on.</a:t>
+DARSHAN: These are the eight parts we used. The Arduino Nano is the controller. The HC-SR04 measures distance. The moisture probe and the LM393 module detect water. The active buzzer gives the alerts. The 18650 battery, the rocker switch and a 220 microfarad capacitor make up the power side. The capacitor smooths the supply so the Nano doesn't reset when the buzzer switches on.</a:t>
             </a:r>
             <a:endParaRPr lang="en-US" dirty="0"/>
           </a:p>
@@ -3874,7 +3874,7 @@
       </p:sp>
       <p:pic>
         <p:nvPicPr>
-          <p:cNvPr id="7" name="prototype photo" descr="img/overview.jpg">    </p:cNvPr>
+          <p:cNvPr id="7" name="prototype photo" descr="img/new_front.jpg">    </p:cNvPr>
           <p:cNvPicPr>
             <a:picLocks noChangeAspect="1"/>
           </p:cNvPicPr>
@@ -3888,8 +3888,8 @@
         </p:blipFill>
         <p:spPr>
           <a:xfrm>
-            <a:off x="5394960" y="1320394"/>
-            <a:ext cx="3291840" cy="2479853"/>
+            <a:off x="5526372" y="548640"/>
+            <a:ext cx="3029015" cy="4023360"/>
           </a:xfrm>
           <a:prstGeom prst="rect">
             <a:avLst/>
@@ -4649,7 +4649,7 @@
       </p:sp>
       <p:pic>
         <p:nvPicPr>
-          <p:cNvPr id="3" name="probe photo" descr="img/probe.jpg">    </p:cNvPr>
+          <p:cNvPr id="3" name="probe photo" descr="img/new_tip.jpg">    </p:cNvPr>
           <p:cNvPicPr>
             <a:picLocks noChangeAspect="1"/>
           </p:cNvPicPr>
@@ -4663,8 +4663,8 @@
         </p:blipFill>
         <p:spPr>
           <a:xfrm>
-            <a:off x="465292" y="1188720"/>
-            <a:ext cx="3641416" cy="2743200"/>
+            <a:off x="1223010" y="1143000"/>
+            <a:ext cx="2125980" cy="2834640"/>
           </a:xfrm>
           <a:prstGeom prst="rect">
             <a:avLst/>
@@ -4701,7 +4701,7 @@
                   <a:schemeClr val="accent5"/>
                 </a:solidFill>
               </a:rPr>
-              <a:t>Moisture probe glued at the cane tip</a:t>
+              <a:t>Probe at the tip, LM393 module above it</a:t>
             </a:r>
             <a:endParaRPr lang="en-US" sz="1100" dirty="0"/>
           </a:p>
@@ -5788,7 +5788,7 @@
       </p:sp>
       <p:pic>
         <p:nvPicPr>
-          <p:cNvPr id="23" name="battery photo" descr="img/battery.jpg">    </p:cNvPr>
+          <p:cNvPr id="23" name="battery and switch photo" descr="img/new_power.jpg">    </p:cNvPr>
           <p:cNvPicPr>
             <a:picLocks noChangeAspect="1"/>
           </p:cNvPicPr>
@@ -5802,8 +5802,8 @@
         </p:blipFill>
         <p:spPr>
           <a:xfrm>
-            <a:off x="6400800" y="1363103"/>
-            <a:ext cx="2286000" cy="3034513"/>
+            <a:off x="6400800" y="1362144"/>
+            <a:ext cx="2286000" cy="3036433"/>
           </a:xfrm>
           <a:prstGeom prst="rect">
             <a:avLst/>
@@ -6048,7 +6048,7 @@
                   <a:schemeClr val="tx1"/>
                 </a:solidFill>
               </a:rPr>
-              <a:t>Capacitor across 5V and GND</a:t>
+              <a:t>220 µF capacitor across 5V and GND</a:t>
             </a:r>
             <a:endParaRPr lang="en-US" sz="1400" dirty="0"/>
           </a:p>
@@ -9850,7 +9850,7 @@
                   <a:schemeClr val="tx2"/>
                 </a:solidFill>
               </a:rPr>
-              <a:t>The prototype</a:t>
+              <a:t>Prototype and assembly</a:t>
             </a:r>
             <a:endParaRPr lang="en-US" sz="3000" dirty="0"/>
           </a:p>
@@ -9858,7 +9858,7 @@
       </p:sp>
       <p:pic>
         <p:nvPicPr>
-          <p:cNvPr id="3" name="prototype photo" descr="img/overview.jpg">    </p:cNvPr>
+          <p:cNvPr id="3" name="prototype photo" descr="img/new_front.jpg">    </p:cNvPr>
           <p:cNvPicPr>
             <a:picLocks noChangeAspect="1"/>
           </p:cNvPicPr>
@@ -9872,17 +9872,53 @@
         </p:blipFill>
         <p:spPr>
           <a:xfrm>
-            <a:off x="467315" y="1097280"/>
-            <a:ext cx="4551770" cy="3429000"/>
+            <a:off x="457200" y="1104819"/>
+            <a:ext cx="2377440" cy="3157890"/>
           </a:xfrm>
           <a:prstGeom prst="rect">
             <a:avLst/>
           </a:prstGeom>
         </p:spPr>
       </p:pic>
+      <p:sp>
+        <p:nvSpPr>
+          <p:cNvPr id="4" name="Text 1"/>
+          <p:cNvSpPr txBox="1"/>
+          <p:nvPr/>
+        </p:nvSpPr>
+        <p:spPr>
+          <a:xfrm>
+            <a:off x="457200" y="4317573"/>
+            <a:ext cx="2377440" cy="274320"/>
+          </a:xfrm>
+          <a:prstGeom prst="rect">
+            <a:avLst/>
+          </a:prstGeom>
+          <a:noFill/>
+          <a:ln/>
+        </p:spPr>
+        <p:txBody>
+          <a:bodyPr wrap="square" lIns="0" tIns="0" rIns="0" bIns="0" rtlCol="0" anchor="t"/>
+          <a:lstStyle/>
+          <a:p>
+            <a:pPr algn="ctr" indent="0" marL="0">
+              <a:buNone/>
+            </a:pPr>
+            <a:r>
+              <a:rPr lang="en-US" sz="1000" i="1" dirty="0">
+                <a:solidFill>
+                  <a:schemeClr val="accent5"/>
+                </a:solidFill>
+              </a:rPr>
+              <a:t>Sensor, Nano, buzzer and switch</a:t>
+            </a:r>
+            <a:endParaRPr lang="en-US" sz="1000" dirty="0"/>
+          </a:p>
+        </p:txBody>
+      </p:sp>
       <p:pic>
         <p:nvPicPr>
-          <p:cNvPr id="4" name="probe photo" descr="img/probe.jpg">    </p:cNvPr>
+          <p:cNvPr id="5" name="prototype photo" descr="img/new_side.jpg">    </p:cNvPr>
           <p:cNvPicPr>
             <a:picLocks noChangeAspect="1"/>
           </p:cNvPicPr>
@@ -9896,96 +9932,24 @@
         </p:blipFill>
         <p:spPr>
           <a:xfrm>
-            <a:off x="5303520" y="1317498"/>
-            <a:ext cx="1600200" cy="1205484"/>
+            <a:off x="2971800" y="1104819"/>
+            <a:ext cx="2377440" cy="3157890"/>
           </a:xfrm>
           <a:prstGeom prst="rect">
             <a:avLst/>
           </a:prstGeom>
         </p:spPr>
       </p:pic>
-      <p:pic>
-        <p:nvPicPr>
-          <p:cNvPr id="5" name="LM393 photo" descr="img/lm393.jpg">    </p:cNvPr>
-          <p:cNvPicPr>
-            <a:picLocks noChangeAspect="1"/>
-          </p:cNvPicPr>
-          <p:nvPr/>
-        </p:nvPicPr>
-        <p:blipFill>
-          <a:blip r:embed="rId3"/>
-          <a:stretch>
-            <a:fillRect/>
-          </a:stretch>
-        </p:blipFill>
-        <p:spPr>
-          <a:xfrm>
-            <a:off x="7086600" y="1317498"/>
-            <a:ext cx="1600200" cy="1205484"/>
-          </a:xfrm>
-          <a:prstGeom prst="rect">
-            <a:avLst/>
-          </a:prstGeom>
-        </p:spPr>
-      </p:pic>
-      <p:pic>
-        <p:nvPicPr>
-          <p:cNvPr id="6" name="battery photo" descr="img/battery.jpg">    </p:cNvPr>
-          <p:cNvPicPr>
-            <a:picLocks noChangeAspect="1"/>
-          </p:cNvPicPr>
-          <p:nvPr/>
-        </p:nvPicPr>
-        <p:blipFill>
-          <a:blip r:embed="rId4"/>
-          <a:stretch>
-            <a:fillRect/>
-          </a:stretch>
-        </p:blipFill>
-        <p:spPr>
-          <a:xfrm>
-            <a:off x="5483657" y="2880360"/>
-            <a:ext cx="1239926" cy="1645920"/>
-          </a:xfrm>
-          <a:prstGeom prst="rect">
-            <a:avLst/>
-          </a:prstGeom>
-        </p:spPr>
-      </p:pic>
-      <p:pic>
-        <p:nvPicPr>
-          <p:cNvPr id="7" name="switch photo" descr="img/switch.jpg">    </p:cNvPr>
-          <p:cNvPicPr>
-            <a:picLocks noChangeAspect="1"/>
-          </p:cNvPicPr>
-          <p:nvPr/>
-        </p:nvPicPr>
-        <p:blipFill>
-          <a:blip r:embed="rId5"/>
-          <a:stretch>
-            <a:fillRect/>
-          </a:stretch>
-        </p:blipFill>
-        <p:spPr>
-          <a:xfrm>
-            <a:off x="7086600" y="3100578"/>
-            <a:ext cx="1600200" cy="1205484"/>
-          </a:xfrm>
-          <a:prstGeom prst="rect">
-            <a:avLst/>
-          </a:prstGeom>
-        </p:spPr>
-      </p:pic>
-      <p:sp>
-        <p:nvSpPr>
-          <p:cNvPr id="8" name="Text 1"/>
+      <p:sp>
+        <p:nvSpPr>
+          <p:cNvPr id="6" name="Text 2"/>
           <p:cNvSpPr txBox="1"/>
           <p:nvPr/>
         </p:nvSpPr>
         <p:spPr>
           <a:xfrm>
-            <a:off x="457200" y="4544568"/>
-            <a:ext cx="8229600" cy="228600"/>
+            <a:off x="2971800" y="4317573"/>
+            <a:ext cx="2377440" cy="274320"/>
           </a:xfrm>
           <a:prstGeom prst="rect">
             <a:avLst/>
@@ -9997,18 +9961,130 @@
           <a:bodyPr wrap="square" lIns="0" tIns="0" rIns="0" bIns="0" rtlCol="0" anchor="t"/>
           <a:lstStyle/>
           <a:p>
-            <a:pPr indent="0" marL="0">
-              <a:buNone/>
-            </a:pPr>
-            <a:r>
-              <a:rPr lang="en-US" sz="1100" i="1" dirty="0">
+            <a:pPr algn="ctr" indent="0" marL="0">
+              <a:buNone/>
+            </a:pPr>
+            <a:r>
+              <a:rPr lang="en-US" sz="1000" i="1" dirty="0">
                 <a:solidFill>
                   <a:schemeClr val="accent5"/>
                 </a:solidFill>
               </a:rPr>
-              <a:t>Sensors, Nano, buzzer and power are mounted along a PVC pipe; the probe sits at the tip</a:t>
-            </a:r>
-            <a:endParaRPr lang="en-US" sz="1100" dirty="0"/>
+              <a:t>Jumpers on header pins, 220 µF capacitor</a:t>
+            </a:r>
+            <a:endParaRPr lang="en-US" sz="1000" dirty="0"/>
+          </a:p>
+        </p:txBody>
+      </p:sp>
+      <p:sp>
+        <p:nvSpPr>
+          <p:cNvPr id="7" name="Text 3"/>
+          <p:cNvSpPr txBox="1"/>
+          <p:nvPr/>
+        </p:nvSpPr>
+        <p:spPr>
+          <a:xfrm>
+            <a:off x="5532120" y="1143000"/>
+            <a:ext cx="3154680" cy="3474720"/>
+          </a:xfrm>
+          <a:prstGeom prst="rect">
+            <a:avLst/>
+          </a:prstGeom>
+          <a:noFill/>
+          <a:ln/>
+        </p:spPr>
+        <p:txBody>
+          <a:bodyPr wrap="square" lIns="0" tIns="0" rIns="0" bIns="0" rtlCol="0" anchor="t"/>
+          <a:lstStyle/>
+          <a:p>
+            <a:pPr marL="342900" indent="-342900">
+              <a:spcAft>
+                <a:spcPts val="800"/>
+              </a:spcAft>
+              <a:buSzPct val="100000"/>
+              <a:buChar char="•"/>
+            </a:pPr>
+            <a:r>
+              <a:rPr lang="en-US" sz="1400" dirty="0">
+                <a:solidFill>
+                  <a:schemeClr val="tx1"/>
+                </a:solidFill>
+              </a:rPr>
+              <a:t>Male header pins soldered onto the Nano</a:t>
+            </a:r>
+            <a:endParaRPr lang="en-US" sz="1400" dirty="0"/>
+          </a:p>
+          <a:p>
+            <a:pPr marL="342900" indent="-342900">
+              <a:spcAft>
+                <a:spcPts val="800"/>
+              </a:spcAft>
+              <a:buSzPct val="100000"/>
+              <a:buChar char="•"/>
+            </a:pPr>
+            <a:r>
+              <a:rPr lang="en-US" sz="1400" dirty="0">
+                <a:solidFill>
+                  <a:schemeClr val="tx1"/>
+                </a:solidFill>
+              </a:rPr>
+              <a:t>Sensors joined with female jumper wires: Trig D5, Echo D6, moisture A0</a:t>
+            </a:r>
+            <a:endParaRPr lang="en-US" sz="1400" dirty="0"/>
+          </a:p>
+          <a:p>
+            <a:pPr marL="342900" indent="-342900">
+              <a:spcAft>
+                <a:spcPts val="800"/>
+              </a:spcAft>
+              <a:buSzPct val="100000"/>
+              <a:buChar char="•"/>
+            </a:pPr>
+            <a:r>
+              <a:rPr lang="en-US" sz="1400" dirty="0">
+                <a:solidFill>
+                  <a:schemeClr val="tx1"/>
+                </a:solidFill>
+              </a:rPr>
+              <a:t>Power wires, buzzer and 220 µF capacitor soldered</a:t>
+            </a:r>
+            <a:endParaRPr lang="en-US" sz="1400" dirty="0"/>
+          </a:p>
+          <a:p>
+            <a:pPr marL="342900" indent="-342900">
+              <a:spcAft>
+                <a:spcPts val="800"/>
+              </a:spcAft>
+              <a:buSzPct val="100000"/>
+              <a:buChar char="•"/>
+            </a:pPr>
+            <a:r>
+              <a:rPr lang="en-US" sz="1400" dirty="0">
+                <a:solidFill>
+                  <a:schemeClr val="tx1"/>
+                </a:solidFill>
+              </a:rPr>
+              <a:t>Parts hot-glued to the PVC pipe; HC-SR04 on a foam spacer; battery cable-tied</a:t>
+            </a:r>
+            <a:endParaRPr lang="en-US" sz="1400" dirty="0"/>
+          </a:p>
+          <a:p>
+            <a:pPr marL="342900" indent="-342900">
+              <a:spcAft>
+                <a:spcPts val="800"/>
+              </a:spcAft>
+              <a:buSzPct val="100000"/>
+              <a:buChar char="•"/>
+            </a:pPr>
+            <a:r>
+              <a:rPr lang="en-US" sz="1400" dirty="0">
+                <a:solidFill>
+                  <a:schemeClr val="tx1"/>
+                </a:solidFill>
+              </a:rPr>
+              <a:t>No breadboard in the final build</a:t>
+            </a:r>
+            <a:endParaRPr lang="en-US" sz="1400" dirty="0"/>
           </a:p>
         </p:txBody>
       </p:sp>
@@ -16461,7 +16537,7 @@
       </p:sp>
       <p:pic>
         <p:nvPicPr>
-          <p:cNvPr id="3" name="prototype photo" descr="img/overview.jpg">    </p:cNvPr>
+          <p:cNvPr id="3" name="prototype photo" descr="img/new_front.jpg">    </p:cNvPr>
           <p:cNvPicPr>
             <a:picLocks noChangeAspect="1"/>
           </p:cNvPicPr>
@@ -16475,8 +16551,8 @@
         </p:blipFill>
         <p:spPr>
           <a:xfrm>
-            <a:off x="457200" y="1364894"/>
-            <a:ext cx="4023360" cy="3030931"/>
+            <a:off x="1160896" y="1143000"/>
+            <a:ext cx="2615968" cy="3474720"/>
           </a:xfrm>
           <a:prstGeom prst="rect">
             <a:avLst/>
@@ -17973,7 +18049,7 @@
                   <a:schemeClr val="accent5"/>
                 </a:solidFill>
               </a:rPr>
-              <a:t>220–470 µF supply filter</a:t>
+              <a:t>220 µF, 50 V supply filter</a:t>
             </a:r>
             <a:endParaRPr lang="en-US" sz="1200" dirty="0"/>
           </a:p>

</xml_diff>

<commit_message>
Presentation: use clean prototype photos; add photos folder to zip
Co-Authored-By: Claude Opus 5.5 <noreply@anthropic.com>
Claude-Session: https://claude.ai/code/session_01RBCZvHRngDWn2z2Egxvtcp
</commit_message>
<xml_diff>
--- a/docs/VisionGuard_Presentation.pptx
+++ b/docs/VisionGuard_Presentation.pptx
@@ -131,7 +131,7 @@
   <p:extLst>
     <p:ext uri="{521415D9-36F7-43E2-AB2F-B90AF26B5E84}">
       <p14:sectionLst xmlns:p14="http://schemas.microsoft.com/office/powerpoint/2010/main">
-        <p14:section name="Introduction" id="{1a6e3766-f72f-8748-af7d-b6b299d4ee24}">
+        <p14:section name="Introduction" id="{6f519897-ec5a-ddc5-6173-32a37a2eba68}">
           <p14:sldIdLst>
             <p14:sldId id="256"/>
             <p14:sldId id="257"/>
@@ -141,7 +141,7 @@
             <p14:sldId id="261"/>
           </p14:sldIdLst>
         </p14:section>
-        <p14:section name="System Design" id="{53747080-8f19-97bf-6de8-a36b3553f8f9}">
+        <p14:section name="System Design" id="{8ae0e863-115d-e1f7-1930-51aa9dbdb8da}">
           <p14:sldIdLst>
             <p14:sldId id="262"/>
             <p14:sldId id="263"/>
@@ -153,7 +153,7 @@
             <p14:sldId id="269"/>
           </p14:sldIdLst>
         </p14:section>
-        <p14:section name="Software" id="{fca74e68-2fe6-01ce-ed75-7adeeac78d16}">
+        <p14:section name="Software" id="{b5a3c7b8-29f4-fd5a-6406-4a45e19d2434}">
           <p14:sldIdLst>
             <p14:sldId id="270"/>
             <p14:sldId id="271"/>
@@ -161,7 +161,7 @@
             <p14:sldId id="273"/>
           </p14:sldIdLst>
         </p14:section>
-        <p14:section name="Results and Conclusion" id="{1089706e-deb7-842b-2a9a-55e8336065bf}">
+        <p14:section name="Results and Conclusion" id="{4343f8ea-b3b3-ebc8-34e6-890626e0cecf}">
           <p14:sldIdLst>
             <p14:sldId id="274"/>
             <p14:sldId id="275"/>
@@ -3874,7 +3874,7 @@
       </p:sp>
       <p:pic>
         <p:nvPicPr>
-          <p:cNvPr id="7" name="prototype photo" descr="img/new_front.jpg">    </p:cNvPr>
+          <p:cNvPr id="7" name="prototype photo" descr="img/clean_full.jpg">    </p:cNvPr>
           <p:cNvPicPr>
             <a:picLocks noChangeAspect="1"/>
           </p:cNvPicPr>
@@ -3888,8 +3888,8 @@
         </p:blipFill>
         <p:spPr>
           <a:xfrm>
-            <a:off x="5526372" y="548640"/>
-            <a:ext cx="3029015" cy="4023360"/>
+            <a:off x="5532120" y="548640"/>
+            <a:ext cx="3017520" cy="4023360"/>
           </a:xfrm>
           <a:prstGeom prst="rect">
             <a:avLst/>
@@ -4649,7 +4649,7 @@
       </p:sp>
       <p:pic>
         <p:nvPicPr>
-          <p:cNvPr id="3" name="probe photo" descr="img/new_tip.jpg">    </p:cNvPr>
+          <p:cNvPr id="3" name="probe photo" descr="img/clean_probe.jpg">    </p:cNvPr>
           <p:cNvPicPr>
             <a:picLocks noChangeAspect="1"/>
           </p:cNvPicPr>
@@ -4701,7 +4701,7 @@
                   <a:schemeClr val="accent5"/>
                 </a:solidFill>
               </a:rPr>
-              <a:t>Probe at the tip, LM393 module above it</a:t>
+              <a:t>Moisture probe at the cane tip: two exposed copper tracks</a:t>
             </a:r>
             <a:endParaRPr lang="en-US" sz="1100" dirty="0"/>
           </a:p>
@@ -9858,7 +9858,7 @@
       </p:sp>
       <p:pic>
         <p:nvPicPr>
-          <p:cNvPr id="3" name="prototype photo" descr="img/new_front.jpg">    </p:cNvPr>
+          <p:cNvPr id="3" name="prototype photo" descr="img/clean_full.jpg">    </p:cNvPr>
           <p:cNvPicPr>
             <a:picLocks noChangeAspect="1"/>
           </p:cNvPicPr>
@@ -9872,8 +9872,8 @@
         </p:blipFill>
         <p:spPr>
           <a:xfrm>
-            <a:off x="457200" y="1104819"/>
-            <a:ext cx="2377440" cy="3157890"/>
+            <a:off x="457200" y="1098804"/>
+            <a:ext cx="2377440" cy="3169920"/>
           </a:xfrm>
           <a:prstGeom prst="rect">
             <a:avLst/>
@@ -9888,7 +9888,7 @@
         </p:nvSpPr>
         <p:spPr>
           <a:xfrm>
-            <a:off x="457200" y="4317573"/>
+            <a:off x="457200" y="4323588"/>
             <a:ext cx="2377440" cy="274320"/>
           </a:xfrm>
           <a:prstGeom prst="rect">
@@ -9910,7 +9910,7 @@
                   <a:schemeClr val="accent5"/>
                 </a:solidFill>
               </a:rPr>
-              <a:t>Sensor, Nano, buzzer and switch</a:t>
+              <a:t>Complete cane, tip at the top</a:t>
             </a:r>
             <a:endParaRPr lang="en-US" sz="1000" dirty="0"/>
           </a:p>
@@ -9918,7 +9918,7 @@
       </p:sp>
       <p:pic>
         <p:nvPicPr>
-          <p:cNvPr id="5" name="prototype photo" descr="img/new_side.jpg">    </p:cNvPr>
+          <p:cNvPr id="5" name="prototype photo" descr="img/clean_modules.jpg">    </p:cNvPr>
           <p:cNvPicPr>
             <a:picLocks noChangeAspect="1"/>
           </p:cNvPicPr>
@@ -9932,8 +9932,8 @@
         </p:blipFill>
         <p:spPr>
           <a:xfrm>
-            <a:off x="2971800" y="1104819"/>
-            <a:ext cx="2377440" cy="3157890"/>
+            <a:off x="2971800" y="1098804"/>
+            <a:ext cx="2377440" cy="3169920"/>
           </a:xfrm>
           <a:prstGeom prst="rect">
             <a:avLst/>
@@ -9948,7 +9948,7 @@
         </p:nvSpPr>
         <p:spPr>
           <a:xfrm>
-            <a:off x="2971800" y="4317573"/>
+            <a:off x="2971800" y="4323588"/>
             <a:ext cx="2377440" cy="274320"/>
           </a:xfrm>
           <a:prstGeom prst="rect">
@@ -9970,7 +9970,7 @@
                   <a:schemeClr val="accent5"/>
                 </a:solidFill>
               </a:rPr>
-              <a:t>Jumpers on header pins, 220 µF capacitor</a:t>
+              <a:t>LM393 and HC-SR04 on female jumpers</a:t>
             </a:r>
             <a:endParaRPr lang="en-US" sz="1000" dirty="0"/>
           </a:p>
@@ -16537,7 +16537,7 @@
       </p:sp>
       <p:pic>
         <p:nvPicPr>
-          <p:cNvPr id="3" name="prototype photo" descr="img/new_front.jpg">    </p:cNvPr>
+          <p:cNvPr id="3" name="cane in use photo" descr="img/clean_inuse.jpg">    </p:cNvPr>
           <p:cNvPicPr>
             <a:picLocks noChangeAspect="1"/>
           </p:cNvPicPr>
@@ -16551,8 +16551,8 @@
         </p:blipFill>
         <p:spPr>
           <a:xfrm>
-            <a:off x="1160896" y="1143000"/>
-            <a:ext cx="2615968" cy="3474720"/>
+            <a:off x="1165860" y="1143000"/>
+            <a:ext cx="2606040" cy="3474720"/>
           </a:xfrm>
           <a:prstGeom prst="rect">
             <a:avLst/>

</xml_diff>

<commit_message>
Update all documents: clean photos, 220 uF capacitor, header-pin wiring, circuit label
Co-Authored-By: Claude Opus 5.5 <noreply@anthropic.com>
Claude-Session: https://claude.ai/code/session_01RBCZvHRngDWn2z2Egxvtcp
</commit_message>
<xml_diff>
--- a/docs/VisionGuard_Presentation.pptx
+++ b/docs/VisionGuard_Presentation.pptx
@@ -131,7 +131,7 @@
   <p:extLst>
     <p:ext uri="{521415D9-36F7-43E2-AB2F-B90AF26B5E84}">
       <p14:sectionLst xmlns:p14="http://schemas.microsoft.com/office/powerpoint/2010/main">
-        <p14:section name="Introduction" id="{6f519897-ec5a-ddc5-6173-32a37a2eba68}">
+        <p14:section name="Introduction" id="{b7f73a0e-cec2-fd0d-7eda-e898d9d38289}">
           <p14:sldIdLst>
             <p14:sldId id="256"/>
             <p14:sldId id="257"/>
@@ -141,7 +141,7 @@
             <p14:sldId id="261"/>
           </p14:sldIdLst>
         </p14:section>
-        <p14:section name="System Design" id="{8ae0e863-115d-e1f7-1930-51aa9dbdb8da}">
+        <p14:section name="System Design" id="{a18c0c64-70f8-6f53-b6e0-3e9f02f802cf}">
           <p14:sldIdLst>
             <p14:sldId id="262"/>
             <p14:sldId id="263"/>
@@ -153,7 +153,7 @@
             <p14:sldId id="269"/>
           </p14:sldIdLst>
         </p14:section>
-        <p14:section name="Software" id="{b5a3c7b8-29f4-fd5a-6406-4a45e19d2434}">
+        <p14:section name="Software" id="{536a0b95-1fdb-c1f6-7abf-2463157e4095}">
           <p14:sldIdLst>
             <p14:sldId id="270"/>
             <p14:sldId id="271"/>
@@ -161,7 +161,7 @@
             <p14:sldId id="273"/>
           </p14:sldIdLst>
         </p14:section>
-        <p14:section name="Results and Conclusion" id="{4343f8ea-b3b3-ebc8-34e6-890626e0cecf}">
+        <p14:section name="Results and Conclusion" id="{e9ffb556-7219-93ac-3bde-f9797a1b3dda}">
           <p14:sldIdLst>
             <p14:sldId id="274"/>
             <p14:sldId id="275"/>

</xml_diff>